<commit_message>
experience/2026: apply user-edited card template to all cards
Adopt the styling from the edited example slides (keynote, MTU, SKF): title
54pt full-width on top, 209px presenter circle beside 36pt company + name,
sim panel at (701,590), larger calendar and 32/20pt venue. Long titles
auto-shrink to fit above the avatar row. Regenerate all 10 PNGs and the
editable square PPTX from one clean 10-slide template.

Co-Authored-By: Claude Opus 4.8 (1M context) <noreply@anthropic.com>
</commit_message>
<xml_diff>
--- a/experience/cards/particleworks-experience-2026-cards.pptx
+++ b/experience/cards/particleworks-experience-2026-cards.pptx
@@ -3225,8 +3225,8 @@
         </p:blipFill>
         <p:spPr>
           <a:xfrm>
-            <a:off x="685800" y="701040"/>
-            <a:ext cx="426720" cy="457200"/>
+            <a:off x="617220" y="655320"/>
+            <a:ext cx="594360" cy="640080"/>
           </a:xfrm>
           <a:prstGeom prst="rect">
             <a:avLst/>
@@ -3312,7 +3312,7 @@
         <p:spPr>
           <a:xfrm>
             <a:off x="685800" y="1813560"/>
-            <a:ext cx="7772400" cy="2286000"/>
+            <a:ext cx="7772400" cy="3566160"/>
           </a:xfrm>
           <a:prstGeom prst="rect">
             <a:avLst/>
@@ -3327,7 +3327,7 @@
           <a:p>
             <a:pPr algn="l"/>
             <a:r>
-              <a:rPr sz="3120" b="1">
+              <a:rPr sz="5400" b="1">
                 <a:solidFill>
                   <a:srgbClr val="FFFFFF"/>
                 </a:solidFill>
@@ -3354,8 +3354,8 @@
         </p:blipFill>
         <p:spPr>
           <a:xfrm>
-            <a:off x="685800" y="4312920"/>
-            <a:ext cx="1188720" cy="1188720"/>
+            <a:off x="807720" y="5349240"/>
+            <a:ext cx="1592580" cy="1592580"/>
           </a:xfrm>
           <a:prstGeom prst="rect">
             <a:avLst/>
@@ -3370,8 +3370,8 @@
         </p:nvSpPr>
         <p:spPr>
           <a:xfrm>
-            <a:off x="2103120" y="4495800"/>
-            <a:ext cx="6355080" cy="457200"/>
+            <a:off x="2628900" y="5593080"/>
+            <a:ext cx="5829300" cy="556260"/>
           </a:xfrm>
           <a:prstGeom prst="rect">
             <a:avLst/>
@@ -3386,7 +3386,7 @@
           <a:p>
             <a:pPr algn="l"/>
             <a:r>
-              <a:rPr sz="2520" b="1">
+              <a:rPr sz="3600" b="1">
                 <a:solidFill>
                   <a:srgbClr val="FFFFFF"/>
                 </a:solidFill>
@@ -3405,8 +3405,8 @@
         </p:nvSpPr>
         <p:spPr>
           <a:xfrm>
-            <a:off x="2103120" y="4953000"/>
-            <a:ext cx="6355080" cy="411480"/>
+            <a:off x="2628900" y="6050280"/>
+            <a:ext cx="5829300" cy="556260"/>
           </a:xfrm>
           <a:prstGeom prst="rect">
             <a:avLst/>
@@ -3421,7 +3421,7 @@
           <a:p>
             <a:pPr algn="l"/>
             <a:r>
-              <a:rPr sz="2280" b="1">
+              <a:rPr sz="3600" b="1">
                 <a:solidFill>
                   <a:srgbClr val="34D27C"/>
                 </a:solidFill>
@@ -3448,7 +3448,7 @@
         </p:blipFill>
         <p:spPr>
           <a:xfrm>
-            <a:off x="685800" y="7467599"/>
+            <a:off x="685800" y="7688580"/>
             <a:ext cx="2651760" cy="944880"/>
           </a:xfrm>
           <a:prstGeom prst="rect">
@@ -3464,8 +3464,8 @@
         </p:nvSpPr>
         <p:spPr>
           <a:xfrm>
-            <a:off x="4190999" y="7955279"/>
-            <a:ext cx="4267200" cy="396240"/>
+            <a:off x="4190999" y="7772400"/>
+            <a:ext cx="4267200" cy="495299"/>
           </a:xfrm>
           <a:prstGeom prst="rect">
             <a:avLst/>
@@ -3480,7 +3480,7 @@
           <a:p>
             <a:pPr algn="r"/>
             <a:r>
-              <a:rPr sz="2400" b="1">
+              <a:rPr sz="3179" b="1">
                 <a:solidFill>
                   <a:srgbClr val="FFFFFF"/>
                 </a:solidFill>
@@ -3499,8 +3499,8 @@
         </p:nvSpPr>
         <p:spPr>
           <a:xfrm>
-            <a:off x="4190999" y="8351520"/>
-            <a:ext cx="4267200" cy="274320"/>
+            <a:off x="4190999" y="8168640"/>
+            <a:ext cx="4267200" cy="304800"/>
           </a:xfrm>
           <a:prstGeom prst="rect">
             <a:avLst/>
@@ -3515,7 +3515,7 @@
           <a:p>
             <a:pPr algn="r"/>
             <a:r>
-              <a:rPr sz="1620" b="1">
+              <a:rPr sz="1980" b="1">
                 <a:solidFill>
                   <a:srgbClr val="FFD9CF"/>
                 </a:solidFill>
@@ -3672,8 +3672,8 @@
         </p:blipFill>
         <p:spPr>
           <a:xfrm>
-            <a:off x="685800" y="701040"/>
-            <a:ext cx="426720" cy="457200"/>
+            <a:off x="617220" y="655320"/>
+            <a:ext cx="594360" cy="640080"/>
           </a:xfrm>
           <a:prstGeom prst="rect">
             <a:avLst/>
@@ -3759,7 +3759,7 @@
         <p:spPr>
           <a:xfrm>
             <a:off x="685800" y="1813560"/>
-            <a:ext cx="7772400" cy="2286000"/>
+            <a:ext cx="7772400" cy="3566160"/>
           </a:xfrm>
           <a:prstGeom prst="rect">
             <a:avLst/>
@@ -3774,7 +3774,7 @@
           <a:p>
             <a:pPr algn="l"/>
             <a:r>
-              <a:rPr sz="3120" b="1">
+              <a:rPr sz="5400" b="1">
                 <a:solidFill>
                   <a:srgbClr val="FFFFFF"/>
                 </a:solidFill>
@@ -3801,8 +3801,8 @@
         </p:blipFill>
         <p:spPr>
           <a:xfrm>
-            <a:off x="685800" y="4312920"/>
-            <a:ext cx="1188720" cy="1188720"/>
+            <a:off x="807720" y="5349240"/>
+            <a:ext cx="1592580" cy="1592580"/>
           </a:xfrm>
           <a:prstGeom prst="rect">
             <a:avLst/>
@@ -3817,8 +3817,8 @@
         </p:nvSpPr>
         <p:spPr>
           <a:xfrm>
-            <a:off x="2103120" y="4495800"/>
-            <a:ext cx="6355080" cy="457200"/>
+            <a:off x="2628900" y="5593080"/>
+            <a:ext cx="5829300" cy="556260"/>
           </a:xfrm>
           <a:prstGeom prst="rect">
             <a:avLst/>
@@ -3833,7 +3833,7 @@
           <a:p>
             <a:pPr algn="l"/>
             <a:r>
-              <a:rPr sz="2520" b="1">
+              <a:rPr sz="3600" b="1">
                 <a:solidFill>
                   <a:srgbClr val="FFFFFF"/>
                 </a:solidFill>
@@ -3852,8 +3852,8 @@
         </p:nvSpPr>
         <p:spPr>
           <a:xfrm>
-            <a:off x="2103120" y="4953000"/>
-            <a:ext cx="6355080" cy="411480"/>
+            <a:off x="2628900" y="6050280"/>
+            <a:ext cx="5829300" cy="556260"/>
           </a:xfrm>
           <a:prstGeom prst="rect">
             <a:avLst/>
@@ -3868,7 +3868,7 @@
           <a:p>
             <a:pPr algn="l"/>
             <a:r>
-              <a:rPr sz="2280" b="1">
+              <a:rPr sz="3600" b="1">
                 <a:solidFill>
                   <a:srgbClr val="34D27C"/>
                 </a:solidFill>
@@ -3895,7 +3895,7 @@
         </p:blipFill>
         <p:spPr>
           <a:xfrm>
-            <a:off x="685800" y="7467599"/>
+            <a:off x="685800" y="7688580"/>
             <a:ext cx="2651760" cy="944880"/>
           </a:xfrm>
           <a:prstGeom prst="rect">
@@ -3911,8 +3911,8 @@
         </p:nvSpPr>
         <p:spPr>
           <a:xfrm>
-            <a:off x="4190999" y="7955279"/>
-            <a:ext cx="4267200" cy="396240"/>
+            <a:off x="4190999" y="7772400"/>
+            <a:ext cx="4267200" cy="495299"/>
           </a:xfrm>
           <a:prstGeom prst="rect">
             <a:avLst/>
@@ -3927,7 +3927,7 @@
           <a:p>
             <a:pPr algn="r"/>
             <a:r>
-              <a:rPr sz="2400" b="1">
+              <a:rPr sz="3179" b="1">
                 <a:solidFill>
                   <a:srgbClr val="FFFFFF"/>
                 </a:solidFill>
@@ -3946,8 +3946,8 @@
         </p:nvSpPr>
         <p:spPr>
           <a:xfrm>
-            <a:off x="4190999" y="8351520"/>
-            <a:ext cx="4267200" cy="274320"/>
+            <a:off x="4190999" y="8168640"/>
+            <a:ext cx="4267200" cy="304800"/>
           </a:xfrm>
           <a:prstGeom prst="rect">
             <a:avLst/>
@@ -3962,7 +3962,7 @@
           <a:p>
             <a:pPr algn="r"/>
             <a:r>
-              <a:rPr sz="1620" b="1">
+              <a:rPr sz="1980" b="1">
                 <a:solidFill>
                   <a:srgbClr val="FFD9CF"/>
                 </a:solidFill>
@@ -4119,8 +4119,8 @@
         </p:blipFill>
         <p:spPr>
           <a:xfrm>
-            <a:off x="685800" y="701040"/>
-            <a:ext cx="426720" cy="457200"/>
+            <a:off x="617220" y="655320"/>
+            <a:ext cx="594360" cy="640080"/>
           </a:xfrm>
           <a:prstGeom prst="rect">
             <a:avLst/>
@@ -4206,7 +4206,7 @@
         <p:spPr>
           <a:xfrm>
             <a:off x="685800" y="1813560"/>
-            <a:ext cx="7772400" cy="2286000"/>
+            <a:ext cx="7772400" cy="3566160"/>
           </a:xfrm>
           <a:prstGeom prst="rect">
             <a:avLst/>
@@ -4221,7 +4221,7 @@
           <a:p>
             <a:pPr algn="l"/>
             <a:r>
-              <a:rPr sz="3120" b="1">
+              <a:rPr sz="5400" b="1">
                 <a:solidFill>
                   <a:srgbClr val="FFFFFF"/>
                 </a:solidFill>
@@ -4248,8 +4248,8 @@
         </p:blipFill>
         <p:spPr>
           <a:xfrm>
-            <a:off x="685800" y="4312920"/>
-            <a:ext cx="1188720" cy="1188720"/>
+            <a:off x="807720" y="5349240"/>
+            <a:ext cx="1592580" cy="1592580"/>
           </a:xfrm>
           <a:prstGeom prst="rect">
             <a:avLst/>
@@ -4264,8 +4264,8 @@
         </p:nvSpPr>
         <p:spPr>
           <a:xfrm>
-            <a:off x="2103120" y="4495800"/>
-            <a:ext cx="6355080" cy="457200"/>
+            <a:off x="2628900" y="5593080"/>
+            <a:ext cx="5829300" cy="556260"/>
           </a:xfrm>
           <a:prstGeom prst="rect">
             <a:avLst/>
@@ -4280,7 +4280,7 @@
           <a:p>
             <a:pPr algn="l"/>
             <a:r>
-              <a:rPr sz="2520" b="1">
+              <a:rPr sz="3600" b="1">
                 <a:solidFill>
                   <a:srgbClr val="FFFFFF"/>
                 </a:solidFill>
@@ -4299,8 +4299,8 @@
         </p:nvSpPr>
         <p:spPr>
           <a:xfrm>
-            <a:off x="2103120" y="4953000"/>
-            <a:ext cx="6355080" cy="411480"/>
+            <a:off x="2628900" y="6050280"/>
+            <a:ext cx="5829300" cy="556260"/>
           </a:xfrm>
           <a:prstGeom prst="rect">
             <a:avLst/>
@@ -4315,7 +4315,7 @@
           <a:p>
             <a:pPr algn="l"/>
             <a:r>
-              <a:rPr sz="2280" b="1">
+              <a:rPr sz="3600" b="1">
                 <a:solidFill>
                   <a:srgbClr val="34D27C"/>
                 </a:solidFill>
@@ -4342,7 +4342,7 @@
         </p:blipFill>
         <p:spPr>
           <a:xfrm>
-            <a:off x="685800" y="7467599"/>
+            <a:off x="685800" y="7688580"/>
             <a:ext cx="2651760" cy="944880"/>
           </a:xfrm>
           <a:prstGeom prst="rect">
@@ -4358,8 +4358,8 @@
         </p:nvSpPr>
         <p:spPr>
           <a:xfrm>
-            <a:off x="4190999" y="7955279"/>
-            <a:ext cx="4267200" cy="396240"/>
+            <a:off x="4190999" y="7772400"/>
+            <a:ext cx="4267200" cy="495299"/>
           </a:xfrm>
           <a:prstGeom prst="rect">
             <a:avLst/>
@@ -4374,7 +4374,7 @@
           <a:p>
             <a:pPr algn="r"/>
             <a:r>
-              <a:rPr sz="2400" b="1">
+              <a:rPr sz="3179" b="1">
                 <a:solidFill>
                   <a:srgbClr val="FFFFFF"/>
                 </a:solidFill>
@@ -4393,8 +4393,8 @@
         </p:nvSpPr>
         <p:spPr>
           <a:xfrm>
-            <a:off x="4190999" y="8351520"/>
-            <a:ext cx="4267200" cy="274320"/>
+            <a:off x="4190999" y="8168640"/>
+            <a:ext cx="4267200" cy="304800"/>
           </a:xfrm>
           <a:prstGeom prst="rect">
             <a:avLst/>
@@ -4409,7 +4409,7 @@
           <a:p>
             <a:pPr algn="r"/>
             <a:r>
-              <a:rPr sz="1620" b="1">
+              <a:rPr sz="1980" b="1">
                 <a:solidFill>
                   <a:srgbClr val="FFD9CF"/>
                 </a:solidFill>
@@ -4566,8 +4566,8 @@
         </p:blipFill>
         <p:spPr>
           <a:xfrm>
-            <a:off x="685800" y="701040"/>
-            <a:ext cx="426720" cy="457200"/>
+            <a:off x="617220" y="655320"/>
+            <a:ext cx="594360" cy="640080"/>
           </a:xfrm>
           <a:prstGeom prst="rect">
             <a:avLst/>
@@ -4653,7 +4653,7 @@
         <p:spPr>
           <a:xfrm>
             <a:off x="685800" y="1813560"/>
-            <a:ext cx="7772400" cy="2286000"/>
+            <a:ext cx="7772400" cy="3566160"/>
           </a:xfrm>
           <a:prstGeom prst="rect">
             <a:avLst/>
@@ -4668,7 +4668,7 @@
           <a:p>
             <a:pPr algn="l"/>
             <a:r>
-              <a:rPr sz="3120" b="1">
+              <a:rPr sz="5400" b="1">
                 <a:solidFill>
                   <a:srgbClr val="FFFFFF"/>
                 </a:solidFill>
@@ -4695,8 +4695,8 @@
         </p:blipFill>
         <p:spPr>
           <a:xfrm>
-            <a:off x="685800" y="4312920"/>
-            <a:ext cx="1188720" cy="1188720"/>
+            <a:off x="807720" y="5349240"/>
+            <a:ext cx="1592580" cy="1592580"/>
           </a:xfrm>
           <a:prstGeom prst="rect">
             <a:avLst/>
@@ -4711,8 +4711,8 @@
         </p:nvSpPr>
         <p:spPr>
           <a:xfrm>
-            <a:off x="2103120" y="4495800"/>
-            <a:ext cx="6355080" cy="457200"/>
+            <a:off x="2628900" y="5593080"/>
+            <a:ext cx="5829300" cy="556260"/>
           </a:xfrm>
           <a:prstGeom prst="rect">
             <a:avLst/>
@@ -4746,8 +4746,8 @@
         </p:nvSpPr>
         <p:spPr>
           <a:xfrm>
-            <a:off x="2103120" y="4953000"/>
-            <a:ext cx="6355080" cy="411480"/>
+            <a:off x="2628900" y="6050280"/>
+            <a:ext cx="5829300" cy="556260"/>
           </a:xfrm>
           <a:prstGeom prst="rect">
             <a:avLst/>
@@ -4762,7 +4762,7 @@
           <a:p>
             <a:pPr algn="l"/>
             <a:r>
-              <a:rPr sz="2280" b="1">
+              <a:rPr sz="3600" b="1">
                 <a:solidFill>
                   <a:srgbClr val="34D27C"/>
                 </a:solidFill>
@@ -4789,7 +4789,7 @@
         </p:blipFill>
         <p:spPr>
           <a:xfrm>
-            <a:off x="685800" y="7467599"/>
+            <a:off x="685800" y="7688580"/>
             <a:ext cx="2651760" cy="944880"/>
           </a:xfrm>
           <a:prstGeom prst="rect">
@@ -4805,8 +4805,8 @@
         </p:nvSpPr>
         <p:spPr>
           <a:xfrm>
-            <a:off x="4190999" y="7955279"/>
-            <a:ext cx="4267200" cy="396240"/>
+            <a:off x="4190999" y="7772400"/>
+            <a:ext cx="4267200" cy="495299"/>
           </a:xfrm>
           <a:prstGeom prst="rect">
             <a:avLst/>
@@ -4821,7 +4821,7 @@
           <a:p>
             <a:pPr algn="r"/>
             <a:r>
-              <a:rPr sz="2400" b="1">
+              <a:rPr sz="3179" b="1">
                 <a:solidFill>
                   <a:srgbClr val="FFFFFF"/>
                 </a:solidFill>
@@ -4840,8 +4840,8 @@
         </p:nvSpPr>
         <p:spPr>
           <a:xfrm>
-            <a:off x="4190999" y="8351520"/>
-            <a:ext cx="4267200" cy="274320"/>
+            <a:off x="4190999" y="8168640"/>
+            <a:ext cx="4267200" cy="304800"/>
           </a:xfrm>
           <a:prstGeom prst="rect">
             <a:avLst/>
@@ -4856,7 +4856,7 @@
           <a:p>
             <a:pPr algn="r"/>
             <a:r>
-              <a:rPr sz="1620" b="1">
+              <a:rPr sz="1980" b="1">
                 <a:solidFill>
                   <a:srgbClr val="FFD9CF"/>
                 </a:solidFill>
@@ -5013,8 +5013,8 @@
         </p:blipFill>
         <p:spPr>
           <a:xfrm>
-            <a:off x="685800" y="701040"/>
-            <a:ext cx="426720" cy="457200"/>
+            <a:off x="617220" y="655320"/>
+            <a:ext cx="594360" cy="640080"/>
           </a:xfrm>
           <a:prstGeom prst="rect">
             <a:avLst/>
@@ -5100,7 +5100,7 @@
         <p:spPr>
           <a:xfrm>
             <a:off x="685800" y="1813560"/>
-            <a:ext cx="7772400" cy="2286000"/>
+            <a:ext cx="7772400" cy="3566160"/>
           </a:xfrm>
           <a:prstGeom prst="rect">
             <a:avLst/>
@@ -5115,7 +5115,7 @@
           <a:p>
             <a:pPr algn="l"/>
             <a:r>
-              <a:rPr sz="3120" b="1">
+              <a:rPr sz="5400" b="1">
                 <a:solidFill>
                   <a:srgbClr val="FFFFFF"/>
                 </a:solidFill>
@@ -5142,8 +5142,8 @@
         </p:blipFill>
         <p:spPr>
           <a:xfrm>
-            <a:off x="685800" y="4312920"/>
-            <a:ext cx="1188720" cy="1188720"/>
+            <a:off x="807720" y="5349240"/>
+            <a:ext cx="1592580" cy="1592580"/>
           </a:xfrm>
           <a:prstGeom prst="rect">
             <a:avLst/>
@@ -5158,8 +5158,8 @@
         </p:nvSpPr>
         <p:spPr>
           <a:xfrm>
-            <a:off x="2103120" y="4495800"/>
-            <a:ext cx="6355080" cy="457200"/>
+            <a:off x="2628900" y="5593080"/>
+            <a:ext cx="5829300" cy="556260"/>
           </a:xfrm>
           <a:prstGeom prst="rect">
             <a:avLst/>
@@ -5174,7 +5174,7 @@
           <a:p>
             <a:pPr algn="l"/>
             <a:r>
-              <a:rPr sz="2520" b="1">
+              <a:rPr sz="3600" b="1">
                 <a:solidFill>
                   <a:srgbClr val="FFFFFF"/>
                 </a:solidFill>
@@ -5193,8 +5193,8 @@
         </p:nvSpPr>
         <p:spPr>
           <a:xfrm>
-            <a:off x="2103120" y="4953000"/>
-            <a:ext cx="6355080" cy="411480"/>
+            <a:off x="2628900" y="6050280"/>
+            <a:ext cx="5829300" cy="556260"/>
           </a:xfrm>
           <a:prstGeom prst="rect">
             <a:avLst/>
@@ -5209,7 +5209,7 @@
           <a:p>
             <a:pPr algn="l"/>
             <a:r>
-              <a:rPr sz="2280" b="1">
+              <a:rPr sz="3600" b="1">
                 <a:solidFill>
                   <a:srgbClr val="34D27C"/>
                 </a:solidFill>
@@ -5236,7 +5236,7 @@
         </p:blipFill>
         <p:spPr>
           <a:xfrm>
-            <a:off x="685800" y="7467599"/>
+            <a:off x="685800" y="7688580"/>
             <a:ext cx="2651760" cy="944880"/>
           </a:xfrm>
           <a:prstGeom prst="rect">
@@ -5252,8 +5252,8 @@
         </p:nvSpPr>
         <p:spPr>
           <a:xfrm>
-            <a:off x="4190999" y="7955279"/>
-            <a:ext cx="4267200" cy="396240"/>
+            <a:off x="4190999" y="7772400"/>
+            <a:ext cx="4267200" cy="495299"/>
           </a:xfrm>
           <a:prstGeom prst="rect">
             <a:avLst/>
@@ -5268,7 +5268,7 @@
           <a:p>
             <a:pPr algn="r"/>
             <a:r>
-              <a:rPr sz="2400" b="1">
+              <a:rPr sz="3179" b="1">
                 <a:solidFill>
                   <a:srgbClr val="FFFFFF"/>
                 </a:solidFill>
@@ -5287,8 +5287,8 @@
         </p:nvSpPr>
         <p:spPr>
           <a:xfrm>
-            <a:off x="4190999" y="8351520"/>
-            <a:ext cx="4267200" cy="274320"/>
+            <a:off x="4190999" y="8168640"/>
+            <a:ext cx="4267200" cy="304800"/>
           </a:xfrm>
           <a:prstGeom prst="rect">
             <a:avLst/>
@@ -5303,7 +5303,7 @@
           <a:p>
             <a:pPr algn="r"/>
             <a:r>
-              <a:rPr sz="1620" b="1">
+              <a:rPr sz="1980" b="1">
                 <a:solidFill>
                   <a:srgbClr val="FFD9CF"/>
                 </a:solidFill>
@@ -5460,8 +5460,8 @@
         </p:blipFill>
         <p:spPr>
           <a:xfrm>
-            <a:off x="685800" y="701040"/>
-            <a:ext cx="426720" cy="457200"/>
+            <a:off x="617220" y="655320"/>
+            <a:ext cx="594360" cy="640080"/>
           </a:xfrm>
           <a:prstGeom prst="rect">
             <a:avLst/>
@@ -5547,7 +5547,7 @@
         <p:spPr>
           <a:xfrm>
             <a:off x="685800" y="1813560"/>
-            <a:ext cx="7772400" cy="2286000"/>
+            <a:ext cx="7772400" cy="3566160"/>
           </a:xfrm>
           <a:prstGeom prst="rect">
             <a:avLst/>
@@ -5562,7 +5562,7 @@
           <a:p>
             <a:pPr algn="l"/>
             <a:r>
-              <a:rPr sz="3120" b="1">
+              <a:rPr sz="5400" b="1">
                 <a:solidFill>
                   <a:srgbClr val="FFFFFF"/>
                 </a:solidFill>
@@ -5589,8 +5589,8 @@
         </p:blipFill>
         <p:spPr>
           <a:xfrm>
-            <a:off x="685800" y="4312920"/>
-            <a:ext cx="1188720" cy="1188720"/>
+            <a:off x="807720" y="5349240"/>
+            <a:ext cx="1592580" cy="1592580"/>
           </a:xfrm>
           <a:prstGeom prst="rect">
             <a:avLst/>
@@ -5605,8 +5605,8 @@
         </p:nvSpPr>
         <p:spPr>
           <a:xfrm>
-            <a:off x="2103120" y="4495800"/>
-            <a:ext cx="6355080" cy="457200"/>
+            <a:off x="2628900" y="5593080"/>
+            <a:ext cx="5829300" cy="556260"/>
           </a:xfrm>
           <a:prstGeom prst="rect">
             <a:avLst/>
@@ -5621,7 +5621,7 @@
           <a:p>
             <a:pPr algn="l"/>
             <a:r>
-              <a:rPr sz="2520" b="1">
+              <a:rPr sz="3600" b="1">
                 <a:solidFill>
                   <a:srgbClr val="FFFFFF"/>
                 </a:solidFill>
@@ -5640,8 +5640,8 @@
         </p:nvSpPr>
         <p:spPr>
           <a:xfrm>
-            <a:off x="2103120" y="4953000"/>
-            <a:ext cx="6355080" cy="411480"/>
+            <a:off x="2628900" y="6050280"/>
+            <a:ext cx="5829300" cy="556260"/>
           </a:xfrm>
           <a:prstGeom prst="rect">
             <a:avLst/>
@@ -5656,7 +5656,7 @@
           <a:p>
             <a:pPr algn="l"/>
             <a:r>
-              <a:rPr sz="2280" b="1">
+              <a:rPr sz="3600" b="1">
                 <a:solidFill>
                   <a:srgbClr val="34D27C"/>
                 </a:solidFill>
@@ -5683,7 +5683,7 @@
         </p:blipFill>
         <p:spPr>
           <a:xfrm>
-            <a:off x="685800" y="7467599"/>
+            <a:off x="685800" y="7688580"/>
             <a:ext cx="2651760" cy="944880"/>
           </a:xfrm>
           <a:prstGeom prst="rect">
@@ -5699,8 +5699,8 @@
         </p:nvSpPr>
         <p:spPr>
           <a:xfrm>
-            <a:off x="4190999" y="7955279"/>
-            <a:ext cx="4267200" cy="396240"/>
+            <a:off x="4190999" y="7772400"/>
+            <a:ext cx="4267200" cy="495299"/>
           </a:xfrm>
           <a:prstGeom prst="rect">
             <a:avLst/>
@@ -5715,7 +5715,7 @@
           <a:p>
             <a:pPr algn="r"/>
             <a:r>
-              <a:rPr sz="2400" b="1">
+              <a:rPr sz="3179" b="1">
                 <a:solidFill>
                   <a:srgbClr val="FFFFFF"/>
                 </a:solidFill>
@@ -5734,8 +5734,8 @@
         </p:nvSpPr>
         <p:spPr>
           <a:xfrm>
-            <a:off x="4190999" y="8351520"/>
-            <a:ext cx="4267200" cy="274320"/>
+            <a:off x="4190999" y="8168640"/>
+            <a:ext cx="4267200" cy="304800"/>
           </a:xfrm>
           <a:prstGeom prst="rect">
             <a:avLst/>
@@ -5750,7 +5750,7 @@
           <a:p>
             <a:pPr algn="r"/>
             <a:r>
-              <a:rPr sz="1620" b="1">
+              <a:rPr sz="1980" b="1">
                 <a:solidFill>
                   <a:srgbClr val="FFD9CF"/>
                 </a:solidFill>
@@ -5907,8 +5907,8 @@
         </p:blipFill>
         <p:spPr>
           <a:xfrm>
-            <a:off x="685800" y="701040"/>
-            <a:ext cx="426720" cy="457200"/>
+            <a:off x="617220" y="655320"/>
+            <a:ext cx="594360" cy="640080"/>
           </a:xfrm>
           <a:prstGeom prst="rect">
             <a:avLst/>
@@ -5994,7 +5994,7 @@
         <p:spPr>
           <a:xfrm>
             <a:off x="685800" y="1813560"/>
-            <a:ext cx="7772400" cy="2286000"/>
+            <a:ext cx="7772400" cy="3566160"/>
           </a:xfrm>
           <a:prstGeom prst="rect">
             <a:avLst/>
@@ -6009,7 +6009,7 @@
           <a:p>
             <a:pPr algn="l"/>
             <a:r>
-              <a:rPr sz="3000" b="1">
+              <a:rPr sz="5400" b="1">
                 <a:solidFill>
                   <a:srgbClr val="FFFFFF"/>
                 </a:solidFill>
@@ -6036,8 +6036,8 @@
         </p:blipFill>
         <p:spPr>
           <a:xfrm>
-            <a:off x="4937760" y="4282440"/>
-            <a:ext cx="3520440" cy="2834640"/>
+            <a:off x="5341620" y="4495800"/>
+            <a:ext cx="3116580" cy="2621280"/>
           </a:xfrm>
           <a:prstGeom prst="rect">
             <a:avLst/>
@@ -6060,8 +6060,8 @@
         </p:blipFill>
         <p:spPr>
           <a:xfrm>
-            <a:off x="685800" y="4312920"/>
-            <a:ext cx="1188720" cy="1188720"/>
+            <a:off x="807720" y="5349240"/>
+            <a:ext cx="1592580" cy="1592580"/>
           </a:xfrm>
           <a:prstGeom prst="rect">
             <a:avLst/>
@@ -6076,8 +6076,8 @@
         </p:nvSpPr>
         <p:spPr>
           <a:xfrm>
-            <a:off x="2103120" y="4495800"/>
-            <a:ext cx="2621280" cy="457200"/>
+            <a:off x="2628900" y="5593080"/>
+            <a:ext cx="2560320" cy="556260"/>
           </a:xfrm>
           <a:prstGeom prst="rect">
             <a:avLst/>
@@ -6092,7 +6092,7 @@
           <a:p>
             <a:pPr algn="l"/>
             <a:r>
-              <a:rPr sz="2520" b="1">
+              <a:rPr sz="3600" b="1">
                 <a:solidFill>
                   <a:srgbClr val="FFFFFF"/>
                 </a:solidFill>
@@ -6111,8 +6111,8 @@
         </p:nvSpPr>
         <p:spPr>
           <a:xfrm>
-            <a:off x="2103120" y="4953000"/>
-            <a:ext cx="2621280" cy="411480"/>
+            <a:off x="2628900" y="6050280"/>
+            <a:ext cx="2560320" cy="556260"/>
           </a:xfrm>
           <a:prstGeom prst="rect">
             <a:avLst/>
@@ -6127,7 +6127,7 @@
           <a:p>
             <a:pPr algn="l"/>
             <a:r>
-              <a:rPr sz="2280" b="1">
+              <a:rPr sz="3600" b="1">
                 <a:solidFill>
                   <a:srgbClr val="34D27C"/>
                 </a:solidFill>
@@ -6154,7 +6154,7 @@
         </p:blipFill>
         <p:spPr>
           <a:xfrm>
-            <a:off x="685800" y="7467599"/>
+            <a:off x="685800" y="7688580"/>
             <a:ext cx="2651760" cy="944880"/>
           </a:xfrm>
           <a:prstGeom prst="rect">
@@ -6170,8 +6170,8 @@
         </p:nvSpPr>
         <p:spPr>
           <a:xfrm>
-            <a:off x="4190999" y="7955279"/>
-            <a:ext cx="4267200" cy="396240"/>
+            <a:off x="4190999" y="7772400"/>
+            <a:ext cx="4267200" cy="495299"/>
           </a:xfrm>
           <a:prstGeom prst="rect">
             <a:avLst/>
@@ -6186,7 +6186,7 @@
           <a:p>
             <a:pPr algn="r"/>
             <a:r>
-              <a:rPr sz="2400" b="1">
+              <a:rPr sz="3179" b="1">
                 <a:solidFill>
                   <a:srgbClr val="FFFFFF"/>
                 </a:solidFill>
@@ -6205,8 +6205,8 @@
         </p:nvSpPr>
         <p:spPr>
           <a:xfrm>
-            <a:off x="4190999" y="8351520"/>
-            <a:ext cx="4267200" cy="274320"/>
+            <a:off x="4190999" y="8168640"/>
+            <a:ext cx="4267200" cy="304800"/>
           </a:xfrm>
           <a:prstGeom prst="rect">
             <a:avLst/>
@@ -6221,7 +6221,7 @@
           <a:p>
             <a:pPr algn="r"/>
             <a:r>
-              <a:rPr sz="1620" b="1">
+              <a:rPr sz="1980" b="1">
                 <a:solidFill>
                   <a:srgbClr val="FFD9CF"/>
                 </a:solidFill>
@@ -6378,8 +6378,8 @@
         </p:blipFill>
         <p:spPr>
           <a:xfrm>
-            <a:off x="685800" y="701040"/>
-            <a:ext cx="426720" cy="457200"/>
+            <a:off x="617220" y="655320"/>
+            <a:ext cx="594360" cy="640080"/>
           </a:xfrm>
           <a:prstGeom prst="rect">
             <a:avLst/>
@@ -6465,7 +6465,7 @@
         <p:spPr>
           <a:xfrm>
             <a:off x="685800" y="1813560"/>
-            <a:ext cx="7772400" cy="2286000"/>
+            <a:ext cx="7772400" cy="3566160"/>
           </a:xfrm>
           <a:prstGeom prst="rect">
             <a:avLst/>
@@ -6480,7 +6480,7 @@
           <a:p>
             <a:pPr algn="l"/>
             <a:r>
-              <a:rPr sz="3000" b="1">
+              <a:rPr sz="5400" b="1">
                 <a:solidFill>
                   <a:srgbClr val="FFFFFF"/>
                 </a:solidFill>
@@ -6507,8 +6507,8 @@
         </p:blipFill>
         <p:spPr>
           <a:xfrm>
-            <a:off x="4937760" y="4282440"/>
-            <a:ext cx="3520440" cy="2834640"/>
+            <a:off x="5341620" y="4495800"/>
+            <a:ext cx="3116580" cy="2621280"/>
           </a:xfrm>
           <a:prstGeom prst="rect">
             <a:avLst/>
@@ -6531,8 +6531,8 @@
         </p:blipFill>
         <p:spPr>
           <a:xfrm>
-            <a:off x="685800" y="4312920"/>
-            <a:ext cx="1188720" cy="1188720"/>
+            <a:off x="807720" y="5349240"/>
+            <a:ext cx="1592580" cy="1592580"/>
           </a:xfrm>
           <a:prstGeom prst="rect">
             <a:avLst/>
@@ -6547,8 +6547,8 @@
         </p:nvSpPr>
         <p:spPr>
           <a:xfrm>
-            <a:off x="2103120" y="4495800"/>
-            <a:ext cx="2621280" cy="457200"/>
+            <a:off x="2628900" y="5593080"/>
+            <a:ext cx="2560320" cy="556260"/>
           </a:xfrm>
           <a:prstGeom prst="rect">
             <a:avLst/>
@@ -6563,7 +6563,7 @@
           <a:p>
             <a:pPr algn="l"/>
             <a:r>
-              <a:rPr sz="2520" b="1">
+              <a:rPr sz="3600" b="1">
                 <a:solidFill>
                   <a:srgbClr val="FFFFFF"/>
                 </a:solidFill>
@@ -6582,8 +6582,8 @@
         </p:nvSpPr>
         <p:spPr>
           <a:xfrm>
-            <a:off x="2103120" y="4953000"/>
-            <a:ext cx="2621280" cy="411480"/>
+            <a:off x="2628900" y="6050280"/>
+            <a:ext cx="2560320" cy="556260"/>
           </a:xfrm>
           <a:prstGeom prst="rect">
             <a:avLst/>
@@ -6598,7 +6598,7 @@
           <a:p>
             <a:pPr algn="l"/>
             <a:r>
-              <a:rPr sz="2280" b="1">
+              <a:rPr sz="2879" b="1">
                 <a:solidFill>
                   <a:srgbClr val="34D27C"/>
                 </a:solidFill>
@@ -6625,7 +6625,7 @@
         </p:blipFill>
         <p:spPr>
           <a:xfrm>
-            <a:off x="685800" y="7467599"/>
+            <a:off x="685800" y="7688580"/>
             <a:ext cx="2651760" cy="944880"/>
           </a:xfrm>
           <a:prstGeom prst="rect">
@@ -6641,8 +6641,8 @@
         </p:nvSpPr>
         <p:spPr>
           <a:xfrm>
-            <a:off x="4190999" y="7955279"/>
-            <a:ext cx="4267200" cy="396240"/>
+            <a:off x="4190999" y="7772400"/>
+            <a:ext cx="4267200" cy="495299"/>
           </a:xfrm>
           <a:prstGeom prst="rect">
             <a:avLst/>
@@ -6657,7 +6657,7 @@
           <a:p>
             <a:pPr algn="r"/>
             <a:r>
-              <a:rPr sz="2400" b="1">
+              <a:rPr sz="3179" b="1">
                 <a:solidFill>
                   <a:srgbClr val="FFFFFF"/>
                 </a:solidFill>
@@ -6676,8 +6676,8 @@
         </p:nvSpPr>
         <p:spPr>
           <a:xfrm>
-            <a:off x="4190999" y="8351520"/>
-            <a:ext cx="4267200" cy="274320"/>
+            <a:off x="4190999" y="8168640"/>
+            <a:ext cx="4267200" cy="304800"/>
           </a:xfrm>
           <a:prstGeom prst="rect">
             <a:avLst/>
@@ -6692,7 +6692,7 @@
           <a:p>
             <a:pPr algn="r"/>
             <a:r>
-              <a:rPr sz="1620" b="1">
+              <a:rPr sz="1980" b="1">
                 <a:solidFill>
                   <a:srgbClr val="FFD9CF"/>
                 </a:solidFill>
@@ -6849,8 +6849,8 @@
         </p:blipFill>
         <p:spPr>
           <a:xfrm>
-            <a:off x="685800" y="701040"/>
-            <a:ext cx="426720" cy="457200"/>
+            <a:off x="617220" y="655320"/>
+            <a:ext cx="594360" cy="640080"/>
           </a:xfrm>
           <a:prstGeom prst="rect">
             <a:avLst/>
@@ -6936,7 +6936,7 @@
         <p:spPr>
           <a:xfrm>
             <a:off x="685800" y="1813560"/>
-            <a:ext cx="7772400" cy="2286000"/>
+            <a:ext cx="7772400" cy="3566160"/>
           </a:xfrm>
           <a:prstGeom prst="rect">
             <a:avLst/>
@@ -6951,7 +6951,7 @@
           <a:p>
             <a:pPr algn="l"/>
             <a:r>
-              <a:rPr sz="3120" b="1">
+              <a:rPr sz="5400" b="1">
                 <a:solidFill>
                   <a:srgbClr val="FFFFFF"/>
                 </a:solidFill>
@@ -6978,8 +6978,8 @@
         </p:blipFill>
         <p:spPr>
           <a:xfrm>
-            <a:off x="685800" y="4312920"/>
-            <a:ext cx="1188720" cy="1188720"/>
+            <a:off x="807720" y="5349240"/>
+            <a:ext cx="1592580" cy="1592580"/>
           </a:xfrm>
           <a:prstGeom prst="rect">
             <a:avLst/>
@@ -6994,8 +6994,8 @@
         </p:nvSpPr>
         <p:spPr>
           <a:xfrm>
-            <a:off x="2103120" y="4495800"/>
-            <a:ext cx="6355080" cy="457200"/>
+            <a:off x="2628900" y="5593080"/>
+            <a:ext cx="5829300" cy="556260"/>
           </a:xfrm>
           <a:prstGeom prst="rect">
             <a:avLst/>
@@ -7010,7 +7010,7 @@
           <a:p>
             <a:pPr algn="l"/>
             <a:r>
-              <a:rPr sz="2520" b="1">
+              <a:rPr sz="3600" b="1">
                 <a:solidFill>
                   <a:srgbClr val="FFFFFF"/>
                 </a:solidFill>
@@ -7029,8 +7029,8 @@
         </p:nvSpPr>
         <p:spPr>
           <a:xfrm>
-            <a:off x="2103120" y="4953000"/>
-            <a:ext cx="6355080" cy="411480"/>
+            <a:off x="2628900" y="6050280"/>
+            <a:ext cx="5829300" cy="556260"/>
           </a:xfrm>
           <a:prstGeom prst="rect">
             <a:avLst/>
@@ -7045,7 +7045,7 @@
           <a:p>
             <a:pPr algn="l"/>
             <a:r>
-              <a:rPr sz="2280" b="1">
+              <a:rPr sz="3600" b="1">
                 <a:solidFill>
                   <a:srgbClr val="34D27C"/>
                 </a:solidFill>
@@ -7072,7 +7072,7 @@
         </p:blipFill>
         <p:spPr>
           <a:xfrm>
-            <a:off x="685800" y="7467599"/>
+            <a:off x="685800" y="7688580"/>
             <a:ext cx="2651760" cy="944880"/>
           </a:xfrm>
           <a:prstGeom prst="rect">
@@ -7088,8 +7088,8 @@
         </p:nvSpPr>
         <p:spPr>
           <a:xfrm>
-            <a:off x="4190999" y="7955279"/>
-            <a:ext cx="4267200" cy="396240"/>
+            <a:off x="4190999" y="7772400"/>
+            <a:ext cx="4267200" cy="495299"/>
           </a:xfrm>
           <a:prstGeom prst="rect">
             <a:avLst/>
@@ -7104,7 +7104,7 @@
           <a:p>
             <a:pPr algn="r"/>
             <a:r>
-              <a:rPr sz="2400" b="1">
+              <a:rPr sz="3179" b="1">
                 <a:solidFill>
                   <a:srgbClr val="FFFFFF"/>
                 </a:solidFill>
@@ -7123,8 +7123,8 @@
         </p:nvSpPr>
         <p:spPr>
           <a:xfrm>
-            <a:off x="4190999" y="8351520"/>
-            <a:ext cx="4267200" cy="274320"/>
+            <a:off x="4190999" y="8168640"/>
+            <a:ext cx="4267200" cy="304800"/>
           </a:xfrm>
           <a:prstGeom prst="rect">
             <a:avLst/>
@@ -7139,7 +7139,7 @@
           <a:p>
             <a:pPr algn="r"/>
             <a:r>
-              <a:rPr sz="1620" b="1">
+              <a:rPr sz="1980" b="1">
                 <a:solidFill>
                   <a:srgbClr val="FFD9CF"/>
                 </a:solidFill>
@@ -7296,8 +7296,8 @@
         </p:blipFill>
         <p:spPr>
           <a:xfrm>
-            <a:off x="685800" y="701040"/>
-            <a:ext cx="426720" cy="457200"/>
+            <a:off x="617220" y="655320"/>
+            <a:ext cx="594360" cy="640080"/>
           </a:xfrm>
           <a:prstGeom prst="rect">
             <a:avLst/>
@@ -7383,7 +7383,7 @@
         <p:spPr>
           <a:xfrm>
             <a:off x="685800" y="1813560"/>
-            <a:ext cx="7772400" cy="2286000"/>
+            <a:ext cx="7772400" cy="3566160"/>
           </a:xfrm>
           <a:prstGeom prst="rect">
             <a:avLst/>
@@ -7398,7 +7398,7 @@
           <a:p>
             <a:pPr algn="l"/>
             <a:r>
-              <a:rPr sz="3000" b="1">
+              <a:rPr sz="5220" b="1">
                 <a:solidFill>
                   <a:srgbClr val="FFFFFF"/>
                 </a:solidFill>
@@ -7425,8 +7425,8 @@
         </p:blipFill>
         <p:spPr>
           <a:xfrm>
-            <a:off x="4937760" y="4282440"/>
-            <a:ext cx="3520440" cy="2834640"/>
+            <a:off x="5341620" y="4495800"/>
+            <a:ext cx="3116580" cy="2621280"/>
           </a:xfrm>
           <a:prstGeom prst="rect">
             <a:avLst/>
@@ -7449,8 +7449,8 @@
         </p:blipFill>
         <p:spPr>
           <a:xfrm>
-            <a:off x="685800" y="4312920"/>
-            <a:ext cx="1188720" cy="1188720"/>
+            <a:off x="807720" y="5349240"/>
+            <a:ext cx="1592580" cy="1592580"/>
           </a:xfrm>
           <a:prstGeom prst="rect">
             <a:avLst/>
@@ -7465,8 +7465,8 @@
         </p:nvSpPr>
         <p:spPr>
           <a:xfrm>
-            <a:off x="2103120" y="4495800"/>
-            <a:ext cx="2621280" cy="457200"/>
+            <a:off x="2628900" y="5593080"/>
+            <a:ext cx="2560320" cy="556260"/>
           </a:xfrm>
           <a:prstGeom prst="rect">
             <a:avLst/>
@@ -7481,7 +7481,7 @@
           <a:p>
             <a:pPr algn="l"/>
             <a:r>
-              <a:rPr sz="2520" b="1">
+              <a:rPr sz="2039" b="1">
                 <a:solidFill>
                   <a:srgbClr val="FFFFFF"/>
                 </a:solidFill>
@@ -7500,8 +7500,8 @@
         </p:nvSpPr>
         <p:spPr>
           <a:xfrm>
-            <a:off x="2103120" y="4953000"/>
-            <a:ext cx="2621280" cy="411480"/>
+            <a:off x="2628900" y="6050280"/>
+            <a:ext cx="2560320" cy="556260"/>
           </a:xfrm>
           <a:prstGeom prst="rect">
             <a:avLst/>
@@ -7516,7 +7516,7 @@
           <a:p>
             <a:pPr algn="l"/>
             <a:r>
-              <a:rPr sz="2280" b="1">
+              <a:rPr sz="3479" b="1">
                 <a:solidFill>
                   <a:srgbClr val="34D27C"/>
                 </a:solidFill>
@@ -7543,7 +7543,7 @@
         </p:blipFill>
         <p:spPr>
           <a:xfrm>
-            <a:off x="685800" y="7467599"/>
+            <a:off x="685800" y="7688580"/>
             <a:ext cx="2651760" cy="944880"/>
           </a:xfrm>
           <a:prstGeom prst="rect">
@@ -7559,8 +7559,8 @@
         </p:nvSpPr>
         <p:spPr>
           <a:xfrm>
-            <a:off x="4190999" y="7955279"/>
-            <a:ext cx="4267200" cy="396240"/>
+            <a:off x="4190999" y="7772400"/>
+            <a:ext cx="4267200" cy="495299"/>
           </a:xfrm>
           <a:prstGeom prst="rect">
             <a:avLst/>
@@ -7575,7 +7575,7 @@
           <a:p>
             <a:pPr algn="r"/>
             <a:r>
-              <a:rPr sz="2400" b="1">
+              <a:rPr sz="3179" b="1">
                 <a:solidFill>
                   <a:srgbClr val="FFFFFF"/>
                 </a:solidFill>
@@ -7594,8 +7594,8 @@
         </p:nvSpPr>
         <p:spPr>
           <a:xfrm>
-            <a:off x="4190999" y="8351520"/>
-            <a:ext cx="4267200" cy="274320"/>
+            <a:off x="4190999" y="8168640"/>
+            <a:ext cx="4267200" cy="304800"/>
           </a:xfrm>
           <a:prstGeom prst="rect">
             <a:avLst/>
@@ -7610,7 +7610,7 @@
           <a:p>
             <a:pPr algn="r"/>
             <a:r>
-              <a:rPr sz="1620" b="1">
+              <a:rPr sz="1980" b="1">
                 <a:solidFill>
                   <a:srgbClr val="FFD9CF"/>
                 </a:solidFill>

</xml_diff>

<commit_message>
experience/2026: regenerate speaker cards with all photos + latest details
- Real photos now on all 10 cards: Lijun Cao (SKF), Leonardo Tiberi
  (Track One), René Kockisch (IAV) replace the LC/LT/RK initials
- Card 01 keynote: add Issei Masaie as co-speaker alongside Iori Saigo
- Card 06 SKF: retitle to "Integrating Particleworks into SKF
  Engineering Tools: Part I — Verification of Heat Transfer Coefficient"
- Drop now-unused initials-avatar generation; refresh editable PPTX

Co-Authored-By: Claude Opus 4.8 (1M context) <noreply@anthropic.com>
</commit_message>
<xml_diff>
--- a/experience/cards/particleworks-experience-2026-cards.pptx
+++ b/experience/cards/particleworks-experience-2026-cards.pptx
@@ -3427,7 +3427,7 @@
                 </a:solidFill>
                 <a:latin typeface="Officina Sans Bold"/>
               </a:rPr>
-              <a:t>Iori Saigo</a:t>
+              <a:t>Issei Masaie · Iori Saigo</a:t>
             </a:r>
           </a:p>
         </p:txBody>
@@ -3787,7 +3787,7 @@
       </p:sp>
       <p:pic>
         <p:nvPicPr>
-          <p:cNvPr id="9" name="Picture 8" descr="av_RK.png"/>
+          <p:cNvPr id="9" name="Picture 8" descr="av_rene-kockisch.png"/>
           <p:cNvPicPr>
             <a:picLocks noChangeAspect="1"/>
           </p:cNvPicPr>
@@ -6015,7 +6015,7 @@
                 </a:solidFill>
                 <a:latin typeface="Officina Sans Bold"/>
               </a:rPr>
-              <a:t>Verification of Heat Transfer Coefficient in Particleworks for Bearings</a:t>
+              <a:t>Integrating Particleworks into SKF Engineering Tools: Part I — Verification of Heat Transfer Coefficient</a:t>
             </a:r>
           </a:p>
         </p:txBody>
@@ -6046,7 +6046,7 @@
       </p:pic>
       <p:pic>
         <p:nvPicPr>
-          <p:cNvPr id="10" name="Picture 9" descr="av_LC.png"/>
+          <p:cNvPr id="10" name="Picture 9" descr="av_lijun-cao.png"/>
           <p:cNvPicPr>
             <a:picLocks noChangeAspect="1"/>
           </p:cNvPicPr>
@@ -6964,7 +6964,7 @@
       </p:sp>
       <p:pic>
         <p:nvPicPr>
-          <p:cNvPr id="9" name="Picture 8" descr="av_LT.png"/>
+          <p:cNvPr id="9" name="Picture 8" descr="av_leonardo-tiberi.png"/>
           <p:cNvPicPr>
             <a:picLocks noChangeAspect="1"/>
           </p:cNvPicPr>

</xml_diff>

<commit_message>
experience/2026: program-announcement card, fix sim/title overlap, target-company lists
- New general card-00-program.png ("THE PROGRAM IS OUT") with an
  application-tag cloud (e-drivetrains, bearings, hydropower, ...)
- Fix title/sim overlap on sim cards: long titles now fit above the
  sim panel (re-rendered card-06 SKF and card-09 Univance)
- LinkedIn doc: add an announcement post + 30 industry-matched
  companies to tag/target under every post; build_posts.py is the
  source of truth, regenerates both .md and .docx

Co-Authored-By: Claude Opus 4.8 (1M context) <noreply@anthropic.com>
</commit_message>
<xml_diff>
--- a/experience/cards/particleworks-experience-2026-cards.pptx
+++ b/experience/cards/particleworks-experience-2026-cards.pptx
@@ -6009,7 +6009,7 @@
           <a:p>
             <a:pPr algn="l"/>
             <a:r>
-              <a:rPr sz="5400" b="1">
+              <a:rPr sz="4320" b="1">
                 <a:solidFill>
                   <a:srgbClr val="FFFFFF"/>
                 </a:solidFill>
@@ -7398,7 +7398,7 @@
           <a:p>
             <a:pPr algn="l"/>
             <a:r>
-              <a:rPr sz="5220" b="1">
+              <a:rPr sz="4320" b="1">
                 <a:solidFill>
                   <a:srgbClr val="FFFFFF"/>
                 </a:solidFill>

</xml_diff>

<commit_message>
experience/2026: re-render cards after generator update; fix card-00 tag overflow
- Run cards_build.py: regenerate all cards incl. card-01 two-title
  keynote (Issei Masaie + Iori Saigo) and refreshed card-00 tag set
- card-00: new longer tag labels wrapped to 4 rows and pushed the CTA
  onto the logo — tighten tag font/spacing so 9 tags fit 3 rows, CTA
  capped above the logo
- Regenerate linkedin-posts .md/.docx from updated build_posts.py
  (keynote split into two presenters) + refresh PPTX

Co-Authored-By: Claude Opus 4.8 (1M context) <noreply@anthropic.com>
</commit_message>
<xml_diff>
--- a/experience/cards/particleworks-experience-2026-cards.pptx
+++ b/experience/cards/particleworks-experience-2026-cards.pptx
@@ -3312,7 +3312,7 @@
         <p:spPr>
           <a:xfrm>
             <a:off x="685800" y="1813560"/>
-            <a:ext cx="7772400" cy="3566160"/>
+            <a:ext cx="7772400" cy="1798320"/>
           </a:xfrm>
           <a:prstGeom prst="rect">
             <a:avLst/>
@@ -3327,20 +3327,55 @@
           <a:p>
             <a:pPr algn="l"/>
             <a:r>
-              <a:rPr sz="5400" b="1">
+              <a:rPr sz="5220" b="1">
                 <a:solidFill>
                   <a:srgbClr val="FFFFFF"/>
                 </a:solidFill>
                 <a:latin typeface="Officina Sans Bold"/>
               </a:rPr>
-              <a:t>What's New in Particleworks 9.0 and Granuleworks 4.0</a:t>
+              <a:t>What's New in Particleworks 9.0 &amp; Granuleworks 4.0</a:t>
+            </a:r>
+          </a:p>
+        </p:txBody>
+      </p:sp>
+      <p:sp>
+        <p:nvSpPr>
+          <p:cNvPr id="9" name="TextBox 8"/>
+          <p:cNvSpPr txBox="1"/>
+          <p:nvPr/>
+        </p:nvSpPr>
+        <p:spPr>
+          <a:xfrm>
+            <a:off x="685800" y="3718560"/>
+            <a:ext cx="7772400" cy="1371600"/>
+          </a:xfrm>
+          <a:prstGeom prst="rect">
+            <a:avLst/>
+          </a:prstGeom>
+          <a:noFill/>
+        </p:spPr>
+        <p:txBody>
+          <a:bodyPr wrap="square" anchor="t" lIns="0" rIns="0" tIns="0" bIns="0">
+            <a:spAutoFit/>
+          </a:bodyPr>
+          <a:lstStyle/>
+          <a:p>
+            <a:pPr algn="l"/>
+            <a:r>
+              <a:rPr sz="3600" b="1">
+                <a:solidFill>
+                  <a:srgbClr val="34D27C"/>
+                </a:solidFill>
+                <a:latin typeface="Officina Sans Bold"/>
+              </a:rPr>
+              <a:t>Application Examples &amp; Case Studies</a:t>
             </a:r>
           </a:p>
         </p:txBody>
       </p:sp>
       <p:pic>
         <p:nvPicPr>
-          <p:cNvPr id="9" name="Picture 8" descr="av_iori-saigo.png"/>
+          <p:cNvPr id="10" name="Picture 9" descr="av_iori-saigo.png"/>
           <p:cNvPicPr>
             <a:picLocks noChangeAspect="1"/>
           </p:cNvPicPr>
@@ -3364,7 +3399,7 @@
       </p:pic>
       <p:sp>
         <p:nvSpPr>
-          <p:cNvPr id="10" name="TextBox 9"/>
+          <p:cNvPr id="11" name="TextBox 10"/>
           <p:cNvSpPr txBox="1"/>
           <p:nvPr/>
         </p:nvSpPr>
@@ -3399,7 +3434,7 @@
       </p:sp>
       <p:sp>
         <p:nvSpPr>
-          <p:cNvPr id="11" name="TextBox 10"/>
+          <p:cNvPr id="12" name="TextBox 11"/>
           <p:cNvSpPr txBox="1"/>
           <p:nvPr/>
         </p:nvSpPr>
@@ -3434,7 +3469,7 @@
       </p:sp>
       <p:pic>
         <p:nvPicPr>
-          <p:cNvPr id="12" name="Picture 11" descr="experience_logo.png"/>
+          <p:cNvPr id="13" name="Picture 12" descr="experience_logo.png"/>
           <p:cNvPicPr>
             <a:picLocks noChangeAspect="1"/>
           </p:cNvPicPr>
@@ -3458,7 +3493,7 @@
       </p:pic>
       <p:sp>
         <p:nvSpPr>
-          <p:cNvPr id="13" name="TextBox 12"/>
+          <p:cNvPr id="14" name="TextBox 13"/>
           <p:cNvSpPr txBox="1"/>
           <p:nvPr/>
         </p:nvSpPr>
@@ -3493,7 +3528,7 @@
       </p:sp>
       <p:sp>
         <p:nvSpPr>
-          <p:cNvPr id="14" name="TextBox 13"/>
+          <p:cNvPr id="15" name="TextBox 14"/>
           <p:cNvSpPr txBox="1"/>
           <p:nvPr/>
         </p:nvSpPr>

</xml_diff>

<commit_message>
experience/2026: match keynote layout in editable PPTX
PPTX slide 1 now mirrors the PNG: two title+speaker segments
(Issei Masaie/initials → 9.0; Iori Saigo/photo → applications),
green divider, both avatars. Keeps deck consistent with the card.

Co-Authored-By: Claude Opus 4.8 (1M context) <noreply@anthropic.com>
</commit_message>
<xml_diff>
--- a/experience/cards/particleworks-experience-2026-cards.pptx
+++ b/experience/cards/particleworks-experience-2026-cards.pptx
@@ -3311,8 +3311,8 @@
         </p:nvSpPr>
         <p:spPr>
           <a:xfrm>
-            <a:off x="685800" y="1813560"/>
-            <a:ext cx="7772400" cy="1798320"/>
+            <a:off x="701040" y="1539240"/>
+            <a:ext cx="6858000" cy="259080"/>
           </a:xfrm>
           <a:prstGeom prst="rect">
             <a:avLst/>
@@ -3327,7 +3327,42 @@
           <a:p>
             <a:pPr algn="l"/>
             <a:r>
-              <a:rPr sz="5220" b="1">
+              <a:rPr sz="1620" b="1">
+                <a:solidFill>
+                  <a:srgbClr val="FFE0D8"/>
+                </a:solidFill>
+                <a:latin typeface="Officina Sans Bold"/>
+              </a:rPr>
+              <a:t>PART 1 · SOFTWARE RELEASE</a:t>
+            </a:r>
+          </a:p>
+        </p:txBody>
+      </p:sp>
+      <p:sp>
+        <p:nvSpPr>
+          <p:cNvPr id="9" name="TextBox 8"/>
+          <p:cNvSpPr txBox="1"/>
+          <p:nvPr/>
+        </p:nvSpPr>
+        <p:spPr>
+          <a:xfrm>
+            <a:off x="685800" y="1844040"/>
+            <a:ext cx="7772400" cy="1188720"/>
+          </a:xfrm>
+          <a:prstGeom prst="rect">
+            <a:avLst/>
+          </a:prstGeom>
+          <a:noFill/>
+        </p:spPr>
+        <p:txBody>
+          <a:bodyPr wrap="square" anchor="t" lIns="0" rIns="0" tIns="0" bIns="0">
+            <a:spAutoFit/>
+          </a:bodyPr>
+          <a:lstStyle/>
+          <a:p>
+            <a:pPr algn="l"/>
+            <a:r>
+              <a:rPr sz="3779" b="1">
                 <a:solidFill>
                   <a:srgbClr val="FFFFFF"/>
                 </a:solidFill>
@@ -3338,44 +3373,9 @@
           </a:p>
         </p:txBody>
       </p:sp>
-      <p:sp>
-        <p:nvSpPr>
-          <p:cNvPr id="9" name="TextBox 8"/>
-          <p:cNvSpPr txBox="1"/>
-          <p:nvPr/>
-        </p:nvSpPr>
-        <p:spPr>
-          <a:xfrm>
-            <a:off x="685800" y="3718560"/>
-            <a:ext cx="7772400" cy="1371600"/>
-          </a:xfrm>
-          <a:prstGeom prst="rect">
-            <a:avLst/>
-          </a:prstGeom>
-          <a:noFill/>
-        </p:spPr>
-        <p:txBody>
-          <a:bodyPr wrap="square" anchor="t" lIns="0" rIns="0" tIns="0" bIns="0">
-            <a:spAutoFit/>
-          </a:bodyPr>
-          <a:lstStyle/>
-          <a:p>
-            <a:pPr algn="l"/>
-            <a:r>
-              <a:rPr sz="3600" b="1">
-                <a:solidFill>
-                  <a:srgbClr val="34D27C"/>
-                </a:solidFill>
-                <a:latin typeface="Officina Sans Bold"/>
-              </a:rPr>
-              <a:t>Application Examples &amp; Case Studies</a:t>
-            </a:r>
-          </a:p>
-        </p:txBody>
-      </p:sp>
       <p:pic>
         <p:nvPicPr>
-          <p:cNvPr id="10" name="Picture 9" descr="av_iori-saigo.png"/>
+          <p:cNvPr id="10" name="Picture 9" descr="av_IM.png"/>
           <p:cNvPicPr>
             <a:picLocks noChangeAspect="1"/>
           </p:cNvPicPr>
@@ -3389,8 +3389,8 @@
         </p:blipFill>
         <p:spPr>
           <a:xfrm>
-            <a:off x="807720" y="5349240"/>
-            <a:ext cx="1592580" cy="1592580"/>
+            <a:off x="701040" y="3078480"/>
+            <a:ext cx="701040" cy="701040"/>
           </a:xfrm>
           <a:prstGeom prst="rect">
             <a:avLst/>
@@ -3405,8 +3405,8 @@
         </p:nvSpPr>
         <p:spPr>
           <a:xfrm>
-            <a:off x="2628900" y="5593080"/>
-            <a:ext cx="5829300" cy="556260"/>
+            <a:off x="1554480" y="3124200"/>
+            <a:ext cx="2743200" cy="396240"/>
           </a:xfrm>
           <a:prstGeom prst="rect">
             <a:avLst/>
@@ -3421,13 +3421,13 @@
           <a:p>
             <a:pPr algn="l"/>
             <a:r>
-              <a:rPr sz="3600" b="1">
+              <a:rPr sz="2400" b="1">
                 <a:solidFill>
                   <a:srgbClr val="FFFFFF"/>
                 </a:solidFill>
                 <a:latin typeface="Officina Sans Bold"/>
               </a:rPr>
-              <a:t>PROMETECH SOFTWARE</a:t>
+              <a:t>Issei Masaie</a:t>
             </a:r>
           </a:p>
         </p:txBody>
@@ -3440,8 +3440,8 @@
         </p:nvSpPr>
         <p:spPr>
           <a:xfrm>
-            <a:off x="2628900" y="6050280"/>
-            <a:ext cx="5829300" cy="556260"/>
+            <a:off x="1554480" y="3474720"/>
+            <a:ext cx="6705600" cy="304800"/>
           </a:xfrm>
           <a:prstGeom prst="rect">
             <a:avLst/>
@@ -3456,20 +3456,90 @@
           <a:p>
             <a:pPr algn="l"/>
             <a:r>
-              <a:rPr sz="3600" b="1">
-                <a:solidFill>
-                  <a:srgbClr val="34D27C"/>
+              <a:rPr sz="1500" b="1">
+                <a:solidFill>
+                  <a:srgbClr val="FFD9CF"/>
                 </a:solidFill>
                 <a:latin typeface="Officina Sans Bold"/>
               </a:rPr>
-              <a:t>Issei Masaie · Iori Saigo</a:t>
+              <a:t>General Manager · Prometech Software</a:t>
+            </a:r>
+          </a:p>
+        </p:txBody>
+      </p:sp>
+      <p:sp>
+        <p:nvSpPr>
+          <p:cNvPr id="13" name="TextBox 12"/>
+          <p:cNvSpPr txBox="1"/>
+          <p:nvPr/>
+        </p:nvSpPr>
+        <p:spPr>
+          <a:xfrm>
+            <a:off x="701040" y="4267200"/>
+            <a:ext cx="6858000" cy="259080"/>
+          </a:xfrm>
+          <a:prstGeom prst="rect">
+            <a:avLst/>
+          </a:prstGeom>
+          <a:noFill/>
+        </p:spPr>
+        <p:txBody>
+          <a:bodyPr wrap="square" anchor="t" lIns="0" rIns="0" tIns="0" bIns="0">
+            <a:spAutoFit/>
+          </a:bodyPr>
+          <a:lstStyle/>
+          <a:p>
+            <a:pPr algn="l"/>
+            <a:r>
+              <a:rPr sz="1620" b="1">
+                <a:solidFill>
+                  <a:srgbClr val="FFE0D8"/>
+                </a:solidFill>
+                <a:latin typeface="Officina Sans Bold"/>
+              </a:rPr>
+              <a:t>PART 2 · APPLICATIONS</a:t>
+            </a:r>
+          </a:p>
+        </p:txBody>
+      </p:sp>
+      <p:sp>
+        <p:nvSpPr>
+          <p:cNvPr id="14" name="TextBox 13"/>
+          <p:cNvSpPr txBox="1"/>
+          <p:nvPr/>
+        </p:nvSpPr>
+        <p:spPr>
+          <a:xfrm>
+            <a:off x="685800" y="4572000"/>
+            <a:ext cx="7772400" cy="655320"/>
+          </a:xfrm>
+          <a:prstGeom prst="rect">
+            <a:avLst/>
+          </a:prstGeom>
+          <a:noFill/>
+        </p:spPr>
+        <p:txBody>
+          <a:bodyPr wrap="square" anchor="t" lIns="0" rIns="0" tIns="0" bIns="0">
+            <a:spAutoFit/>
+          </a:bodyPr>
+          <a:lstStyle/>
+          <a:p>
+            <a:pPr algn="l"/>
+            <a:r>
+              <a:rPr sz="3960" b="1">
+                <a:solidFill>
+                  <a:srgbClr val="34D27C"/>
+                </a:solidFill>
+                <a:latin typeface="Officina Sans Bold"/>
+              </a:rPr>
+              <a:t>Application Examples &amp; Case Studies</a:t>
             </a:r>
           </a:p>
         </p:txBody>
       </p:sp>
       <p:pic>
         <p:nvPicPr>
-          <p:cNvPr id="13" name="Picture 12" descr="experience_logo.png"/>
+          <p:cNvPr id="15" name="Picture 14" descr="av_iori-saigo.png"/>
           <p:cNvPicPr>
             <a:picLocks noChangeAspect="1"/>
           </p:cNvPicPr>
@@ -3483,8 +3553,8 @@
         </p:blipFill>
         <p:spPr>
           <a:xfrm>
-            <a:off x="685800" y="7688580"/>
-            <a:ext cx="2651760" cy="944880"/>
+            <a:off x="701040" y="5273040"/>
+            <a:ext cx="701040" cy="701040"/>
           </a:xfrm>
           <a:prstGeom prst="rect">
             <a:avLst/>
@@ -3493,14 +3563,14 @@
       </p:pic>
       <p:sp>
         <p:nvSpPr>
-          <p:cNvPr id="14" name="TextBox 13"/>
+          <p:cNvPr id="16" name="TextBox 15"/>
           <p:cNvSpPr txBox="1"/>
           <p:nvPr/>
         </p:nvSpPr>
         <p:spPr>
           <a:xfrm>
-            <a:off x="4190999" y="7772400"/>
-            <a:ext cx="4267200" cy="495299"/>
+            <a:off x="1554480" y="5318760"/>
+            <a:ext cx="2743200" cy="396240"/>
           </a:xfrm>
           <a:prstGeom prst="rect">
             <a:avLst/>
@@ -3513,6 +3583,144 @@
           </a:bodyPr>
           <a:lstStyle/>
           <a:p>
+            <a:pPr algn="l"/>
+            <a:r>
+              <a:rPr sz="2400" b="1">
+                <a:solidFill>
+                  <a:srgbClr val="FFFFFF"/>
+                </a:solidFill>
+                <a:latin typeface="Officina Sans Bold"/>
+              </a:rPr>
+              <a:t>Iori Saigo</a:t>
+            </a:r>
+          </a:p>
+        </p:txBody>
+      </p:sp>
+      <p:sp>
+        <p:nvSpPr>
+          <p:cNvPr id="17" name="TextBox 16"/>
+          <p:cNvSpPr txBox="1"/>
+          <p:nvPr/>
+        </p:nvSpPr>
+        <p:spPr>
+          <a:xfrm>
+            <a:off x="1554480" y="5669280"/>
+            <a:ext cx="6705600" cy="304800"/>
+          </a:xfrm>
+          <a:prstGeom prst="rect">
+            <a:avLst/>
+          </a:prstGeom>
+          <a:noFill/>
+        </p:spPr>
+        <p:txBody>
+          <a:bodyPr wrap="square" anchor="t" lIns="0" rIns="0" tIns="0" bIns="0">
+            <a:spAutoFit/>
+          </a:bodyPr>
+          <a:lstStyle/>
+          <a:p>
+            <a:pPr algn="l"/>
+            <a:r>
+              <a:rPr sz="1500" b="1">
+                <a:solidFill>
+                  <a:srgbClr val="FFD9CF"/>
+                </a:solidFill>
+                <a:latin typeface="Officina Sans Bold"/>
+              </a:rPr>
+              <a:t>Application Engineer · Prometech Software</a:t>
+            </a:r>
+          </a:p>
+        </p:txBody>
+      </p:sp>
+      <p:sp>
+        <p:nvSpPr>
+          <p:cNvPr id="18" name="Rectangle 17"/>
+          <p:cNvSpPr/>
+          <p:nvPr/>
+        </p:nvSpPr>
+        <p:spPr>
+          <a:xfrm>
+            <a:off x="701040" y="3992879"/>
+            <a:ext cx="1066800" cy="45720"/>
+          </a:xfrm>
+          <a:prstGeom prst="rect">
+            <a:avLst/>
+          </a:prstGeom>
+          <a:solidFill>
+            <a:srgbClr val="34D27C"/>
+          </a:solidFill>
+          <a:ln>
+            <a:noFill/>
+          </a:ln>
+          <a:effectLst/>
+        </p:spPr>
+        <p:style>
+          <a:lnRef idx="1">
+            <a:schemeClr val="accent1"/>
+          </a:lnRef>
+          <a:fillRef idx="3">
+            <a:schemeClr val="accent1"/>
+          </a:fillRef>
+          <a:effectRef idx="2">
+            <a:schemeClr val="accent1"/>
+          </a:effectRef>
+          <a:fontRef idx="minor">
+            <a:schemeClr val="lt1"/>
+          </a:fontRef>
+        </p:style>
+        <p:txBody>
+          <a:bodyPr rtlCol="0" anchor="ctr"/>
+          <a:lstStyle/>
+          <a:p>
+            <a:pPr algn="ctr"/>
+          </a:p>
+        </p:txBody>
+      </p:sp>
+      <p:pic>
+        <p:nvPicPr>
+          <p:cNvPr id="19" name="Picture 18" descr="experience_logo.png"/>
+          <p:cNvPicPr>
+            <a:picLocks noChangeAspect="1"/>
+          </p:cNvPicPr>
+          <p:nvPr/>
+        </p:nvPicPr>
+        <p:blipFill>
+          <a:blip r:embed="rId6"/>
+          <a:stretch>
+            <a:fillRect/>
+          </a:stretch>
+        </p:blipFill>
+        <p:spPr>
+          <a:xfrm>
+            <a:off x="685800" y="7688580"/>
+            <a:ext cx="2651760" cy="944880"/>
+          </a:xfrm>
+          <a:prstGeom prst="rect">
+            <a:avLst/>
+          </a:prstGeom>
+        </p:spPr>
+      </p:pic>
+      <p:sp>
+        <p:nvSpPr>
+          <p:cNvPr id="20" name="TextBox 19"/>
+          <p:cNvSpPr txBox="1"/>
+          <p:nvPr/>
+        </p:nvSpPr>
+        <p:spPr>
+          <a:xfrm>
+            <a:off x="4190999" y="7772400"/>
+            <a:ext cx="4267200" cy="495299"/>
+          </a:xfrm>
+          <a:prstGeom prst="rect">
+            <a:avLst/>
+          </a:prstGeom>
+          <a:noFill/>
+        </p:spPr>
+        <p:txBody>
+          <a:bodyPr wrap="square" anchor="t" lIns="0" rIns="0" tIns="0" bIns="0">
+            <a:spAutoFit/>
+          </a:bodyPr>
+          <a:lstStyle/>
+          <a:p>
             <a:pPr algn="r"/>
             <a:r>
               <a:rPr sz="3179" b="1">
@@ -3528,7 +3736,7 @@
       </p:sp>
       <p:sp>
         <p:nvSpPr>
-          <p:cNvPr id="15" name="TextBox 14"/>
+          <p:cNvPr id="21" name="TextBox 20"/>
           <p:cNvSpPr txBox="1"/>
           <p:nvPr/>
         </p:nvSpPr>

</xml_diff>

<commit_message>
experience/2026: add Börger FlowSep talk (Valtwies + Sala)
New 11th talk — "Simulation of Sand Separation and Wear in the Börger
FlowSep" by Bernd Valtwies (Börger GmbH) with co-presenter Riccardo Sala
(EnginSoft).

- cards: new dual-speaker card-11-boerger.png (two avatars + FlowSep panel);
  cards_build.py gains a two-speaker footer layout; speaker grid → 12 faces
  (Bernd + Riccardo adjacent); program/speaker counts 10 → 11 talks; PPTX
  re-rendered
- program.html/php: TALK 10 article #talk-flowsep with custom centrifugal
  SVG, both speakers, abstract, authors; hero 11 talks
- index.html/php: Börger topic card (Börger GmbH · EnginSoft)
- linkedin-posts-2026 (md + docx): new Börger post + updated program-out
  counts, via build_posts.py
- teaser: rewritten as a frame-accurate cardboard stop-motion concept
- assets: bernd-valtwies + riccardo-sala headshots, boerger-flowsep image

Co-Authored-By: Claude Opus 4.8 (1M context) <noreply@anthropic.com>
</commit_message>
<xml_diff>
--- a/experience/cards/particleworks-experience-2026-cards.pptx
+++ b/experience/cards/particleworks-experience-2026-cards.pptx
@@ -15,6 +15,7 @@
     <p:sldId id="263" r:id="rId14"/>
     <p:sldId id="264" r:id="rId15"/>
     <p:sldId id="265" r:id="rId16"/>
+    <p:sldId id="266" r:id="rId17"/>
   </p:sldIdLst>
   <p:sldSz cx="9144000" cy="9144000" type="screen4x3"/>
   <p:notesSz cx="6858000" cy="9144000"/>
@@ -4184,6 +4185,571 @@
       <p:sp>
         <p:nvSpPr>
           <p:cNvPr id="14" name="TextBox 13"/>
+          <p:cNvSpPr txBox="1"/>
+          <p:nvPr/>
+        </p:nvSpPr>
+        <p:spPr>
+          <a:xfrm>
+            <a:off x="4190999" y="8168640"/>
+            <a:ext cx="4267200" cy="304800"/>
+          </a:xfrm>
+          <a:prstGeom prst="rect">
+            <a:avLst/>
+          </a:prstGeom>
+          <a:noFill/>
+        </p:spPr>
+        <p:txBody>
+          <a:bodyPr wrap="square" anchor="t" lIns="0" rIns="0" tIns="0" bIns="0">
+            <a:spAutoFit/>
+          </a:bodyPr>
+          <a:lstStyle/>
+          <a:p>
+            <a:pPr algn="r"/>
+            <a:r>
+              <a:rPr sz="1980" b="1">
+                <a:solidFill>
+                  <a:srgbClr val="FFD9CF"/>
+                </a:solidFill>
+                <a:latin typeface="Officina Sans Bold"/>
+              </a:rPr>
+              <a:t>BPER FORUM Monzani</a:t>
+            </a:r>
+          </a:p>
+        </p:txBody>
+      </p:sp>
+    </p:spTree>
+  </p:cSld>
+  <p:clrMapOvr>
+    <a:masterClrMapping/>
+  </p:clrMapOvr>
+</p:sld>
+</file>
+
+<file path=ppt/slides/slide11.xml><?xml version="1.0" encoding="utf-8"?>
+<p:sld xmlns:a="http://schemas.openxmlformats.org/drawingml/2006/main" xmlns:p="http://schemas.openxmlformats.org/presentationml/2006/main" xmlns:r="http://schemas.openxmlformats.org/officeDocument/2006/relationships">
+  <p:cSld>
+    <p:spTree>
+      <p:nvGrpSpPr>
+        <p:cNvPr id="1" name=""/>
+        <p:cNvGrpSpPr/>
+        <p:nvPr/>
+      </p:nvGrpSpPr>
+      <p:grpSpPr/>
+      <p:pic>
+        <p:nvPicPr>
+          <p:cNvPr id="2" name="Picture 1" descr="bg_square.png"/>
+          <p:cNvPicPr>
+            <a:picLocks noChangeAspect="1"/>
+          </p:cNvPicPr>
+          <p:nvPr/>
+        </p:nvPicPr>
+        <p:blipFill>
+          <a:blip r:embed="rId2"/>
+          <a:stretch>
+            <a:fillRect/>
+          </a:stretch>
+        </p:blipFill>
+        <p:spPr>
+          <a:xfrm>
+            <a:off x="0" y="0"/>
+            <a:ext cx="9144000" cy="9144000"/>
+          </a:xfrm>
+          <a:prstGeom prst="rect">
+            <a:avLst/>
+          </a:prstGeom>
+        </p:spPr>
+      </p:pic>
+      <p:sp>
+        <p:nvSpPr>
+          <p:cNvPr id="3" name="Rectangle 2"/>
+          <p:cNvSpPr/>
+          <p:nvPr/>
+        </p:nvSpPr>
+        <p:spPr>
+          <a:xfrm>
+            <a:off x="228600" y="228600"/>
+            <a:ext cx="8686800" cy="8686800"/>
+          </a:xfrm>
+          <a:prstGeom prst="rect">
+            <a:avLst/>
+          </a:prstGeom>
+          <a:noFill/>
+          <a:ln w="25400">
+            <a:solidFill>
+              <a:srgbClr val="FFFFFF"/>
+            </a:solidFill>
+          </a:ln>
+          <a:effectLst/>
+        </p:spPr>
+        <p:style>
+          <a:lnRef idx="1">
+            <a:schemeClr val="accent1"/>
+          </a:lnRef>
+          <a:fillRef idx="3">
+            <a:schemeClr val="accent1"/>
+          </a:fillRef>
+          <a:effectRef idx="2">
+            <a:schemeClr val="accent1"/>
+          </a:effectRef>
+          <a:fontRef idx="minor">
+            <a:schemeClr val="lt1"/>
+          </a:fontRef>
+        </p:style>
+        <p:txBody>
+          <a:bodyPr rtlCol="0" anchor="ctr"/>
+          <a:lstStyle/>
+          <a:p>
+            <a:pPr algn="ctr"/>
+          </a:p>
+        </p:txBody>
+      </p:sp>
+      <p:sp>
+        <p:nvSpPr>
+          <p:cNvPr id="4" name="Rectangle 3"/>
+          <p:cNvSpPr/>
+          <p:nvPr/>
+        </p:nvSpPr>
+        <p:spPr>
+          <a:xfrm>
+            <a:off x="365760" y="365760"/>
+            <a:ext cx="8412480" cy="8412480"/>
+          </a:xfrm>
+          <a:prstGeom prst="rect">
+            <a:avLst/>
+          </a:prstGeom>
+          <a:noFill/>
+          <a:ln w="38100">
+            <a:solidFill>
+              <a:srgbClr val="34D27C"/>
+            </a:solidFill>
+          </a:ln>
+          <a:effectLst/>
+        </p:spPr>
+        <p:style>
+          <a:lnRef idx="1">
+            <a:schemeClr val="accent1"/>
+          </a:lnRef>
+          <a:fillRef idx="3">
+            <a:schemeClr val="accent1"/>
+          </a:fillRef>
+          <a:effectRef idx="2">
+            <a:schemeClr val="accent1"/>
+          </a:effectRef>
+          <a:fontRef idx="minor">
+            <a:schemeClr val="lt1"/>
+          </a:fontRef>
+        </p:style>
+        <p:txBody>
+          <a:bodyPr rtlCol="0" anchor="ctr"/>
+          <a:lstStyle/>
+          <a:p>
+            <a:pPr algn="ctr"/>
+          </a:p>
+        </p:txBody>
+      </p:sp>
+      <p:pic>
+        <p:nvPicPr>
+          <p:cNvPr id="5" name="Picture 4" descr="cal.png"/>
+          <p:cNvPicPr>
+            <a:picLocks noChangeAspect="1"/>
+          </p:cNvPicPr>
+          <p:nvPr/>
+        </p:nvPicPr>
+        <p:blipFill>
+          <a:blip r:embed="rId3"/>
+          <a:stretch>
+            <a:fillRect/>
+          </a:stretch>
+        </p:blipFill>
+        <p:spPr>
+          <a:xfrm>
+            <a:off x="617220" y="655320"/>
+            <a:ext cx="594360" cy="640080"/>
+          </a:xfrm>
+          <a:prstGeom prst="rect">
+            <a:avLst/>
+          </a:prstGeom>
+        </p:spPr>
+      </p:pic>
+      <p:sp>
+        <p:nvSpPr>
+          <p:cNvPr id="6" name="TextBox 5"/>
+          <p:cNvSpPr txBox="1"/>
+          <p:nvPr/>
+        </p:nvSpPr>
+        <p:spPr>
+          <a:xfrm>
+            <a:off x="1280160" y="655320"/>
+            <a:ext cx="3962399" cy="396240"/>
+          </a:xfrm>
+          <a:prstGeom prst="rect">
+            <a:avLst/>
+          </a:prstGeom>
+          <a:noFill/>
+        </p:spPr>
+        <p:txBody>
+          <a:bodyPr wrap="square" anchor="t" lIns="0" rIns="0" tIns="0" bIns="0">
+            <a:spAutoFit/>
+          </a:bodyPr>
+          <a:lstStyle/>
+          <a:p>
+            <a:pPr algn="l"/>
+            <a:r>
+              <a:rPr sz="2520" b="1">
+                <a:solidFill>
+                  <a:srgbClr val="FFFFFF"/>
+                </a:solidFill>
+                <a:latin typeface="Officina Sans Bold"/>
+              </a:rPr>
+              <a:t>October 7, 2026</a:t>
+            </a:r>
+          </a:p>
+        </p:txBody>
+      </p:sp>
+      <p:sp>
+        <p:nvSpPr>
+          <p:cNvPr id="7" name="TextBox 6"/>
+          <p:cNvSpPr txBox="1"/>
+          <p:nvPr/>
+        </p:nvSpPr>
+        <p:spPr>
+          <a:xfrm>
+            <a:off x="1280160" y="1066800"/>
+            <a:ext cx="3962399" cy="259080"/>
+          </a:xfrm>
+          <a:prstGeom prst="rect">
+            <a:avLst/>
+          </a:prstGeom>
+          <a:noFill/>
+        </p:spPr>
+        <p:txBody>
+          <a:bodyPr wrap="square" anchor="t" lIns="0" rIns="0" tIns="0" bIns="0">
+            <a:spAutoFit/>
+          </a:bodyPr>
+          <a:lstStyle/>
+          <a:p>
+            <a:pPr algn="l"/>
+            <a:r>
+              <a:rPr sz="1560" b="1">
+                <a:solidFill>
+                  <a:srgbClr val="FFE0D8"/>
+                </a:solidFill>
+                <a:latin typeface="Officina Sans Bold"/>
+              </a:rPr>
+              <a:t>Industrial speaker</a:t>
+            </a:r>
+          </a:p>
+        </p:txBody>
+      </p:sp>
+      <p:sp>
+        <p:nvSpPr>
+          <p:cNvPr id="8" name="TextBox 7"/>
+          <p:cNvSpPr txBox="1"/>
+          <p:nvPr/>
+        </p:nvSpPr>
+        <p:spPr>
+          <a:xfrm>
+            <a:off x="685800" y="1813560"/>
+            <a:ext cx="7772400" cy="3566160"/>
+          </a:xfrm>
+          <a:prstGeom prst="rect">
+            <a:avLst/>
+          </a:prstGeom>
+          <a:noFill/>
+        </p:spPr>
+        <p:txBody>
+          <a:bodyPr wrap="square" anchor="t" lIns="0" rIns="0" tIns="0" bIns="0">
+            <a:spAutoFit/>
+          </a:bodyPr>
+          <a:lstStyle/>
+          <a:p>
+            <a:pPr algn="l"/>
+            <a:r>
+              <a:rPr sz="5400" b="1">
+                <a:solidFill>
+                  <a:srgbClr val="FFFFFF"/>
+                </a:solidFill>
+                <a:latin typeface="Officina Sans Bold"/>
+              </a:rPr>
+              <a:t>Simulation of Sand Separation and Wear in the Börger FlowSep</a:t>
+            </a:r>
+          </a:p>
+        </p:txBody>
+      </p:sp>
+      <p:pic>
+        <p:nvPicPr>
+          <p:cNvPr id="9" name="Picture 8" descr="sim_flowsep.png"/>
+          <p:cNvPicPr>
+            <a:picLocks noChangeAspect="1"/>
+          </p:cNvPicPr>
+          <p:nvPr/>
+        </p:nvPicPr>
+        <p:blipFill>
+          <a:blip r:embed="rId4"/>
+          <a:stretch>
+            <a:fillRect/>
+          </a:stretch>
+        </p:blipFill>
+        <p:spPr>
+          <a:xfrm>
+            <a:off x="5341620" y="4495800"/>
+            <a:ext cx="3116580" cy="2621280"/>
+          </a:xfrm>
+          <a:prstGeom prst="rect">
+            <a:avLst/>
+          </a:prstGeom>
+        </p:spPr>
+      </p:pic>
+      <p:pic>
+        <p:nvPicPr>
+          <p:cNvPr id="10" name="Picture 9" descr="av_bernd-valtwies.png"/>
+          <p:cNvPicPr>
+            <a:picLocks noChangeAspect="1"/>
+          </p:cNvPicPr>
+          <p:nvPr/>
+        </p:nvPicPr>
+        <p:blipFill>
+          <a:blip r:embed="rId5"/>
+          <a:stretch>
+            <a:fillRect/>
+          </a:stretch>
+        </p:blipFill>
+        <p:spPr>
+          <a:xfrm>
+            <a:off x="807720" y="4937760"/>
+            <a:ext cx="1143000" cy="1143000"/>
+          </a:xfrm>
+          <a:prstGeom prst="rect">
+            <a:avLst/>
+          </a:prstGeom>
+        </p:spPr>
+      </p:pic>
+      <p:sp>
+        <p:nvSpPr>
+          <p:cNvPr id="11" name="TextBox 10"/>
+          <p:cNvSpPr txBox="1"/>
+          <p:nvPr/>
+        </p:nvSpPr>
+        <p:spPr>
+          <a:xfrm>
+            <a:off x="2103120" y="5196840"/>
+            <a:ext cx="3147060" cy="457200"/>
+          </a:xfrm>
+          <a:prstGeom prst="rect">
+            <a:avLst/>
+          </a:prstGeom>
+          <a:noFill/>
+        </p:spPr>
+        <p:txBody>
+          <a:bodyPr wrap="square" anchor="t" lIns="0" rIns="0" tIns="0" bIns="0">
+            <a:spAutoFit/>
+          </a:bodyPr>
+          <a:lstStyle/>
+          <a:p>
+            <a:pPr algn="l"/>
+            <a:r>
+              <a:rPr sz="3240" b="1">
+                <a:solidFill>
+                  <a:srgbClr val="FFFFFF"/>
+                </a:solidFill>
+                <a:latin typeface="Officina Sans Bold"/>
+              </a:rPr>
+              <a:t>Bernd Valtwies</a:t>
+            </a:r>
+          </a:p>
+        </p:txBody>
+      </p:sp>
+      <p:sp>
+        <p:nvSpPr>
+          <p:cNvPr id="12" name="TextBox 11"/>
+          <p:cNvSpPr txBox="1"/>
+          <p:nvPr/>
+        </p:nvSpPr>
+        <p:spPr>
+          <a:xfrm>
+            <a:off x="2103120" y="5684520"/>
+            <a:ext cx="3147060" cy="365760"/>
+          </a:xfrm>
+          <a:prstGeom prst="rect">
+            <a:avLst/>
+          </a:prstGeom>
+          <a:noFill/>
+        </p:spPr>
+        <p:txBody>
+          <a:bodyPr wrap="square" anchor="t" lIns="0" rIns="0" tIns="0" bIns="0">
+            <a:spAutoFit/>
+          </a:bodyPr>
+          <a:lstStyle/>
+          <a:p>
+            <a:pPr algn="l"/>
+            <a:r>
+              <a:rPr sz="2520" b="1">
+                <a:solidFill>
+                  <a:srgbClr val="34D27C"/>
+                </a:solidFill>
+                <a:latin typeface="Officina Sans Bold"/>
+              </a:rPr>
+              <a:t>BÖRGER GMBH</a:t>
+            </a:r>
+          </a:p>
+        </p:txBody>
+      </p:sp>
+      <p:pic>
+        <p:nvPicPr>
+          <p:cNvPr id="13" name="Picture 12" descr="av_riccardo-sala.png"/>
+          <p:cNvPicPr>
+            <a:picLocks noChangeAspect="1"/>
+          </p:cNvPicPr>
+          <p:nvPr/>
+        </p:nvPicPr>
+        <p:blipFill>
+          <a:blip r:embed="rId6"/>
+          <a:stretch>
+            <a:fillRect/>
+          </a:stretch>
+        </p:blipFill>
+        <p:spPr>
+          <a:xfrm>
+            <a:off x="807720" y="6187440"/>
+            <a:ext cx="1143000" cy="1143000"/>
+          </a:xfrm>
+          <a:prstGeom prst="rect">
+            <a:avLst/>
+          </a:prstGeom>
+        </p:spPr>
+      </p:pic>
+      <p:sp>
+        <p:nvSpPr>
+          <p:cNvPr id="14" name="TextBox 13"/>
+          <p:cNvSpPr txBox="1"/>
+          <p:nvPr/>
+        </p:nvSpPr>
+        <p:spPr>
+          <a:xfrm>
+            <a:off x="2103120" y="6446520"/>
+            <a:ext cx="3147060" cy="457200"/>
+          </a:xfrm>
+          <a:prstGeom prst="rect">
+            <a:avLst/>
+          </a:prstGeom>
+          <a:noFill/>
+        </p:spPr>
+        <p:txBody>
+          <a:bodyPr wrap="square" anchor="t" lIns="0" rIns="0" tIns="0" bIns="0">
+            <a:spAutoFit/>
+          </a:bodyPr>
+          <a:lstStyle/>
+          <a:p>
+            <a:pPr algn="l"/>
+            <a:r>
+              <a:rPr sz="3240" b="1">
+                <a:solidFill>
+                  <a:srgbClr val="FFFFFF"/>
+                </a:solidFill>
+                <a:latin typeface="Officina Sans Bold"/>
+              </a:rPr>
+              <a:t>Riccardo Sala</a:t>
+            </a:r>
+          </a:p>
+        </p:txBody>
+      </p:sp>
+      <p:sp>
+        <p:nvSpPr>
+          <p:cNvPr id="15" name="TextBox 14"/>
+          <p:cNvSpPr txBox="1"/>
+          <p:nvPr/>
+        </p:nvSpPr>
+        <p:spPr>
+          <a:xfrm>
+            <a:off x="2103120" y="6934200"/>
+            <a:ext cx="3147060" cy="365760"/>
+          </a:xfrm>
+          <a:prstGeom prst="rect">
+            <a:avLst/>
+          </a:prstGeom>
+          <a:noFill/>
+        </p:spPr>
+        <p:txBody>
+          <a:bodyPr wrap="square" anchor="t" lIns="0" rIns="0" tIns="0" bIns="0">
+            <a:spAutoFit/>
+          </a:bodyPr>
+          <a:lstStyle/>
+          <a:p>
+            <a:pPr algn="l"/>
+            <a:r>
+              <a:rPr sz="2520" b="1">
+                <a:solidFill>
+                  <a:srgbClr val="34D27C"/>
+                </a:solidFill>
+                <a:latin typeface="Officina Sans Bold"/>
+              </a:rPr>
+              <a:t>ENGINSOFT</a:t>
+            </a:r>
+          </a:p>
+        </p:txBody>
+      </p:sp>
+      <p:pic>
+        <p:nvPicPr>
+          <p:cNvPr id="16" name="Picture 15" descr="experience_logo.png"/>
+          <p:cNvPicPr>
+            <a:picLocks noChangeAspect="1"/>
+          </p:cNvPicPr>
+          <p:nvPr/>
+        </p:nvPicPr>
+        <p:blipFill>
+          <a:blip r:embed="rId7"/>
+          <a:stretch>
+            <a:fillRect/>
+          </a:stretch>
+        </p:blipFill>
+        <p:spPr>
+          <a:xfrm>
+            <a:off x="685800" y="7688580"/>
+            <a:ext cx="2651760" cy="944880"/>
+          </a:xfrm>
+          <a:prstGeom prst="rect">
+            <a:avLst/>
+          </a:prstGeom>
+        </p:spPr>
+      </p:pic>
+      <p:sp>
+        <p:nvSpPr>
+          <p:cNvPr id="17" name="TextBox 16"/>
+          <p:cNvSpPr txBox="1"/>
+          <p:nvPr/>
+        </p:nvSpPr>
+        <p:spPr>
+          <a:xfrm>
+            <a:off x="4190999" y="7772400"/>
+            <a:ext cx="4267200" cy="495299"/>
+          </a:xfrm>
+          <a:prstGeom prst="rect">
+            <a:avLst/>
+          </a:prstGeom>
+          <a:noFill/>
+        </p:spPr>
+        <p:txBody>
+          <a:bodyPr wrap="square" anchor="t" lIns="0" rIns="0" tIns="0" bIns="0">
+            <a:spAutoFit/>
+          </a:bodyPr>
+          <a:lstStyle/>
+          <a:p>
+            <a:pPr algn="r"/>
+            <a:r>
+              <a:rPr sz="3179" b="1">
+                <a:solidFill>
+                  <a:srgbClr val="FFFFFF"/>
+                </a:solidFill>
+                <a:latin typeface="Officina Sans Bold"/>
+              </a:rPr>
+              <a:t>Modena, Italy</a:t>
+            </a:r>
+          </a:p>
+        </p:txBody>
+      </p:sp>
+      <p:sp>
+        <p:nvSpPr>
+          <p:cNvPr id="18" name="TextBox 17"/>
           <p:cNvSpPr txBox="1"/>
           <p:nvPr/>
         </p:nvSpPr>

</xml_diff>